<commit_message>
Deck: apply the 22 verified corrections to the comparison table (page 27), in the main deck, the PDF and the user's own PowerPoint and PDF
Co-Authored-By: Claude Sonnet 5.5 <noreply@anthropic.com>
</commit_message>
<xml_diff>
--- a/marketing/presentation/Smart-Assess-Ja-Manchester-Presentation-v2-with-your-edits.pptx
+++ b/marketing/presentation/Smart-Assess-Ja-Manchester-Presentation-v2-with-your-edits.pptx
@@ -37388,17 +37388,17 @@
                         <a:buNone/>
                       </a:pPr>
                       <a:r>
-                        <a:rPr lang="en-US" sz="800" dirty="0">
+                        <a:rPr lang="en-US" sz="850" b="1" dirty="0">
                           <a:solidFill>
-                            <a:srgbClr val="8A7A62"/>
+                            <a:srgbClr val="1E1208"/>
                           </a:solidFill>
                           <a:latin typeface="Arial" pitchFamily="34" charset="0"/>
                           <a:ea typeface="Arial" pitchFamily="34" charset="-122"/>
                           <a:cs typeface="Arial" pitchFamily="34" charset="-120"/>
                         </a:rPr>
-                        <a:t>–</a:t>
+                        <a:t>✔</a:t>
                       </a:r>
-                      <a:endParaRPr lang="en-US" sz="800" dirty="0">
+                      <a:endParaRPr lang="en-US" sz="850" dirty="0">
                         <a:latin typeface="Arial" charset="0"/>
                         <a:ea typeface="Arial" charset="0"/>
                         <a:cs typeface="Arial" charset="0"/>
@@ -37438,17 +37438,17 @@
                         <a:buNone/>
                       </a:pPr>
                       <a:r>
-                        <a:rPr lang="en-US" sz="800" dirty="0">
+                        <a:rPr lang="en-US" sz="850" b="1" dirty="0">
                           <a:solidFill>
-                            <a:srgbClr val="8A7A62"/>
+                            <a:srgbClr val="1E1208"/>
                           </a:solidFill>
                           <a:latin typeface="Arial" pitchFamily="34" charset="0"/>
                           <a:ea typeface="Arial" pitchFamily="34" charset="-122"/>
                           <a:cs typeface="Arial" pitchFamily="34" charset="-120"/>
                         </a:rPr>
-                        <a:t>–</a:t>
+                        <a:t>✔</a:t>
                       </a:r>
-                      <a:endParaRPr lang="en-US" sz="800" dirty="0">
+                      <a:endParaRPr lang="en-US" sz="850" dirty="0">
                         <a:latin typeface="Arial" charset="0"/>
                         <a:ea typeface="Arial" charset="0"/>
                         <a:cs typeface="Arial" charset="0"/>
@@ -38442,17 +38442,17 @@
                         <a:buNone/>
                       </a:pPr>
                       <a:r>
-                        <a:rPr lang="en-US" sz="680" dirty="0">
+                        <a:rPr lang="en-US" sz="850" b="1" dirty="0">
                           <a:solidFill>
-                            <a:srgbClr val="8A7A62"/>
+                            <a:srgbClr val="1E1208"/>
                           </a:solidFill>
                           <a:latin typeface="Arial" pitchFamily="34" charset="0"/>
                           <a:ea typeface="Arial" pitchFamily="34" charset="-122"/>
                           <a:cs typeface="Arial" pitchFamily="34" charset="-120"/>
                         </a:rPr>
-                        <a:t>Limited</a:t>
+                        <a:t>✔</a:t>
                       </a:r>
-                      <a:endParaRPr lang="en-US" sz="680" dirty="0">
+                      <a:endParaRPr lang="en-US" sz="850" dirty="0">
                         <a:latin typeface="Arial" charset="0"/>
                         <a:ea typeface="Arial" charset="0"/>
                         <a:cs typeface="Arial" charset="0"/>
@@ -38996,17 +38996,17 @@
                         <a:buNone/>
                       </a:pPr>
                       <a:r>
-                        <a:rPr lang="en-US" sz="800" dirty="0">
+                        <a:rPr lang="en-US" sz="850" b="1" dirty="0">
                           <a:solidFill>
-                            <a:srgbClr val="8A7A62"/>
+                            <a:srgbClr val="1E1208"/>
                           </a:solidFill>
                           <a:latin typeface="Arial" pitchFamily="34" charset="0"/>
                           <a:ea typeface="Arial" pitchFamily="34" charset="-122"/>
                           <a:cs typeface="Arial" pitchFamily="34" charset="-120"/>
                         </a:rPr>
-                        <a:t>–</a:t>
+                        <a:t>✔</a:t>
                       </a:r>
-                      <a:endParaRPr lang="en-US" sz="800" dirty="0">
+                      <a:endParaRPr lang="en-US" sz="850" dirty="0">
                         <a:latin typeface="Arial" charset="0"/>
                         <a:ea typeface="Arial" charset="0"/>
                         <a:cs typeface="Arial" charset="0"/>
@@ -39046,17 +39046,17 @@
                         <a:buNone/>
                       </a:pPr>
                       <a:r>
-                        <a:rPr lang="en-US" sz="800" dirty="0">
+                        <a:rPr lang="en-US" sz="850" b="1" dirty="0">
                           <a:solidFill>
-                            <a:srgbClr val="8A7A62"/>
+                            <a:srgbClr val="1E1208"/>
                           </a:solidFill>
                           <a:latin typeface="Arial" pitchFamily="34" charset="0"/>
                           <a:ea typeface="Arial" pitchFamily="34" charset="-122"/>
                           <a:cs typeface="Arial" pitchFamily="34" charset="-120"/>
                         </a:rPr>
-                        <a:t>–</a:t>
+                        <a:t>✔</a:t>
                       </a:r>
-                      <a:endParaRPr lang="en-US" sz="800" dirty="0">
+                      <a:endParaRPr lang="en-US" sz="850" dirty="0">
                         <a:latin typeface="Arial" charset="0"/>
                         <a:ea typeface="Arial" charset="0"/>
                         <a:cs typeface="Arial" charset="0"/>
@@ -39246,7 +39246,7 @@
                         <a:buNone/>
                       </a:pPr>
                       <a:r>
-                        <a:rPr lang="en-US" sz="800" dirty="0">
+                        <a:rPr lang="en-US" sz="680" dirty="0">
                           <a:solidFill>
                             <a:srgbClr val="8A7A62"/>
                           </a:solidFill>
@@ -39254,9 +39254,9 @@
                           <a:ea typeface="Arial" pitchFamily="34" charset="-122"/>
                           <a:cs typeface="Arial" pitchFamily="34" charset="-120"/>
                         </a:rPr>
-                        <a:t>–</a:t>
+                        <a:t>Limited</a:t>
                       </a:r>
-                      <a:endParaRPr lang="en-US" sz="800" dirty="0">
+                      <a:endParaRPr lang="en-US" sz="680" dirty="0">
                         <a:latin typeface="Arial" charset="0"/>
                         <a:ea typeface="Arial" charset="0"/>
                         <a:cs typeface="Arial" charset="0"/>
@@ -39398,7 +39398,7 @@
                         <a:buNone/>
                       </a:pPr>
                       <a:r>
-                        <a:rPr lang="en-US" sz="800" dirty="0">
+                        <a:rPr lang="en-US" sz="680" dirty="0">
                           <a:solidFill>
                             <a:srgbClr val="8A7A62"/>
                           </a:solidFill>
@@ -39406,9 +39406,9 @@
                           <a:ea typeface="Arial" pitchFamily="34" charset="-122"/>
                           <a:cs typeface="Arial" pitchFamily="34" charset="-120"/>
                         </a:rPr>
-                        <a:t>–</a:t>
+                        <a:t>Limited</a:t>
                       </a:r>
-                      <a:endParaRPr lang="en-US" sz="800" dirty="0">
+                      <a:endParaRPr lang="en-US" sz="680" dirty="0">
                         <a:latin typeface="Arial" charset="0"/>
                         <a:ea typeface="Arial" charset="0"/>
                         <a:cs typeface="Arial" charset="0"/>
@@ -39498,7 +39498,7 @@
                         <a:buNone/>
                       </a:pPr>
                       <a:r>
-                        <a:rPr lang="en-US" sz="800" dirty="0">
+                        <a:rPr lang="en-US" sz="680" dirty="0">
                           <a:solidFill>
                             <a:srgbClr val="8A7A62"/>
                           </a:solidFill>
@@ -39506,9 +39506,9 @@
                           <a:ea typeface="Arial" pitchFamily="34" charset="-122"/>
                           <a:cs typeface="Arial" pitchFamily="34" charset="-120"/>
                         </a:rPr>
-                        <a:t>–</a:t>
+                        <a:t>Limited</a:t>
                       </a:r>
-                      <a:endParaRPr lang="en-US" sz="800" dirty="0">
+                      <a:endParaRPr lang="en-US" sz="680" dirty="0">
                         <a:latin typeface="Arial" charset="0"/>
                         <a:ea typeface="Arial" charset="0"/>
                         <a:cs typeface="Arial" charset="0"/>
@@ -39548,7 +39548,7 @@
                         <a:buNone/>
                       </a:pPr>
                       <a:r>
-                        <a:rPr lang="en-US" sz="800" dirty="0">
+                        <a:rPr lang="en-US" sz="680" dirty="0">
                           <a:solidFill>
                             <a:srgbClr val="8A7A62"/>
                           </a:solidFill>
@@ -39556,9 +39556,9 @@
                           <a:ea typeface="Arial" pitchFamily="34" charset="-122"/>
                           <a:cs typeface="Arial" pitchFamily="34" charset="-120"/>
                         </a:rPr>
-                        <a:t>–</a:t>
+                        <a:t>Limited</a:t>
                       </a:r>
-                      <a:endParaRPr lang="en-US" sz="800" dirty="0">
+                      <a:endParaRPr lang="en-US" sz="680" dirty="0">
                         <a:latin typeface="Arial" charset="0"/>
                         <a:ea typeface="Arial" charset="0"/>
                         <a:cs typeface="Arial" charset="0"/>
@@ -39867,7 +39867,7 @@
                         <a:buNone/>
                       </a:pPr>
                       <a:r>
-                        <a:rPr lang="en-US" sz="800" dirty="0">
+                        <a:rPr lang="en-US" sz="680" dirty="0">
                           <a:solidFill>
                             <a:srgbClr val="8A7A62"/>
                           </a:solidFill>
@@ -39875,9 +39875,9 @@
                           <a:ea typeface="Arial" pitchFamily="34" charset="-122"/>
                           <a:cs typeface="Arial" pitchFamily="34" charset="-120"/>
                         </a:rPr>
-                        <a:t>–</a:t>
+                        <a:t>Limited</a:t>
                       </a:r>
-                      <a:endParaRPr lang="en-US" sz="800" dirty="0">
+                      <a:endParaRPr lang="en-US" sz="680" dirty="0">
                         <a:latin typeface="Arial" charset="0"/>
                         <a:ea typeface="Arial" charset="0"/>
                         <a:cs typeface="Arial" charset="0"/>
@@ -39917,7 +39917,7 @@
                         <a:buNone/>
                       </a:pPr>
                       <a:r>
-                        <a:rPr lang="en-US" sz="800" dirty="0">
+                        <a:rPr lang="en-US" sz="680" dirty="0">
                           <a:solidFill>
                             <a:srgbClr val="8A7A62"/>
                           </a:solidFill>
@@ -39925,9 +39925,9 @@
                           <a:ea typeface="Arial" pitchFamily="34" charset="-122"/>
                           <a:cs typeface="Arial" pitchFamily="34" charset="-120"/>
                         </a:rPr>
-                        <a:t>–</a:t>
+                        <a:t>Limited</a:t>
                       </a:r>
-                      <a:endParaRPr lang="en-US" sz="800" dirty="0">
+                      <a:endParaRPr lang="en-US" sz="680" dirty="0">
                         <a:latin typeface="Arial" charset="0"/>
                         <a:ea typeface="Arial" charset="0"/>
                         <a:cs typeface="Arial" charset="0"/>
@@ -40469,7 +40469,7 @@
                         <a:buNone/>
                       </a:pPr>
                       <a:r>
-                        <a:rPr lang="en-US" sz="800" dirty="0">
+                        <a:rPr lang="en-US" sz="680" dirty="0">
                           <a:solidFill>
                             <a:srgbClr val="8A7A62"/>
                           </a:solidFill>
@@ -40477,9 +40477,9 @@
                           <a:ea typeface="Arial" pitchFamily="34" charset="-122"/>
                           <a:cs typeface="Arial" pitchFamily="34" charset="-120"/>
                         </a:rPr>
-                        <a:t>–</a:t>
+                        <a:t>Limited</a:t>
                       </a:r>
-                      <a:endParaRPr lang="en-US" sz="800" dirty="0">
+                      <a:endParaRPr lang="en-US" sz="680" dirty="0">
                         <a:latin typeface="Arial" charset="0"/>
                         <a:ea typeface="Arial" charset="0"/>
                         <a:cs typeface="Arial" charset="0"/>
@@ -40519,17 +40519,17 @@
                         <a:buNone/>
                       </a:pPr>
                       <a:r>
-                        <a:rPr lang="en-US" sz="800" dirty="0">
+                        <a:rPr lang="en-US" sz="850" b="1" dirty="0">
                           <a:solidFill>
-                            <a:srgbClr val="8A7A62"/>
+                            <a:srgbClr val="1E1208"/>
                           </a:solidFill>
                           <a:latin typeface="Arial" pitchFamily="34" charset="0"/>
                           <a:ea typeface="Arial" pitchFamily="34" charset="-122"/>
                           <a:cs typeface="Arial" pitchFamily="34" charset="-120"/>
                         </a:rPr>
-                        <a:t>–</a:t>
+                        <a:t>✔</a:t>
                       </a:r>
-                      <a:endParaRPr lang="en-US" sz="800" dirty="0">
+                      <a:endParaRPr lang="en-US" sz="850" dirty="0">
                         <a:latin typeface="Arial" charset="0"/>
                         <a:ea typeface="Arial" charset="0"/>
                         <a:cs typeface="Arial" charset="0"/>
@@ -41073,17 +41073,67 @@
                         <a:buNone/>
                       </a:pPr>
                       <a:r>
-                        <a:rPr lang="en-US" sz="680" dirty="0">
+                        <a:rPr lang="en-US" sz="850" b="1" dirty="0">
                           <a:solidFill>
-                            <a:srgbClr val="8A7A62"/>
+                            <a:srgbClr val="1E1208"/>
                           </a:solidFill>
                           <a:latin typeface="Arial" pitchFamily="34" charset="0"/>
                           <a:ea typeface="Arial" pitchFamily="34" charset="-122"/>
                           <a:cs typeface="Arial" pitchFamily="34" charset="-120"/>
                         </a:rPr>
-                        <a:t>Limited</a:t>
+                        <a:t>✔</a:t>
                       </a:r>
-                      <a:endParaRPr lang="en-US" sz="680" dirty="0">
+                      <a:endParaRPr lang="en-US" sz="850" dirty="0">
+                        <a:latin typeface="Arial" charset="0"/>
+                        <a:ea typeface="Arial" charset="0"/>
+                        <a:cs typeface="Arial" charset="0"/>
+                      </a:endParaRPr>
+                    </a:p>
+                  </a:txBody>
+                  <a:tcPr marL="18288" marR="18288" marT="0" marB="0" anchor="ctr">
+                    <a:lnL w="0" cap="flat" cmpd="sng" algn="ctr">
+                      <a:noFill/>
+                    </a:lnL>
+                    <a:lnR w="0" cap="flat" cmpd="sng" algn="ctr">
+                      <a:noFill/>
+                    </a:lnR>
+                    <a:lnT w="0" cap="flat" cmpd="sng" algn="ctr">
+                      <a:noFill/>
+                    </a:lnT>
+                    <a:lnB w="6350" cap="flat" cmpd="sng" algn="ctr">
+                      <a:solidFill>
+                        <a:srgbClr val="E5DDD0"/>
+                      </a:solidFill>
+                      <a:prstDash val="solid"/>
+                      <a:round/>
+                      <a:headEnd type="none" w="med" len="med"/>
+                      <a:tailEnd type="none" w="med" len="med"/>
+                    </a:lnB>
+                    <a:solidFill>
+                      <a:srgbClr val="FFFFFF"/>
+                    </a:solidFill>
+                  </a:tcPr>
+                </a:tc>
+                <a:tc>
+                  <a:txBody>
+                    <a:bodyPr/>
+                    <a:lstStyle/>
+                    <a:p>
+                      <a:pPr algn="ctr" indent="0" marL="0">
+                        <a:buNone/>
+                      </a:pPr>
+                      <a:r>
+                        <a:rPr lang="en-US" sz="850" b="1" dirty="0">
+                          <a:solidFill>
+                            <a:srgbClr val="1E1208"/>
+                          </a:solidFill>
+                          <a:latin typeface="Arial" pitchFamily="34" charset="0"/>
+                          <a:ea typeface="Arial" pitchFamily="34" charset="-122"/>
+                          <a:cs typeface="Arial" pitchFamily="34" charset="-120"/>
+                        </a:rPr>
+                        <a:t>✔</a:t>
+                      </a:r>
+                      <a:endParaRPr lang="en-US" sz="850" dirty="0">
                         <a:latin typeface="Arial" charset="0"/>
                         <a:ea typeface="Arial" charset="0"/>
                         <a:cs typeface="Arial" charset="0"/>
@@ -41273,7 +41323,7 @@
                         <a:buNone/>
                       </a:pPr>
                       <a:r>
-                        <a:rPr lang="en-US" sz="800" dirty="0">
+                        <a:rPr lang="en-US" sz="680" dirty="0">
                           <a:solidFill>
                             <a:srgbClr val="8A7A62"/>
                           </a:solidFill>
@@ -41281,59 +41331,9 @@
                           <a:ea typeface="Arial" pitchFamily="34" charset="-122"/>
                           <a:cs typeface="Arial" pitchFamily="34" charset="-120"/>
                         </a:rPr>
-                        <a:t>–</a:t>
+                        <a:t>Limited</a:t>
                       </a:r>
-                      <a:endParaRPr lang="en-US" sz="800" dirty="0">
-                        <a:latin typeface="Arial" charset="0"/>
-                        <a:ea typeface="Arial" charset="0"/>
-                        <a:cs typeface="Arial" charset="0"/>
-                      </a:endParaRPr>
-                    </a:p>
-                  </a:txBody>
-                  <a:tcPr marL="18288" marR="18288" marT="0" marB="0" anchor="ctr">
-                    <a:lnL w="0" cap="flat" cmpd="sng" algn="ctr">
-                      <a:noFill/>
-                    </a:lnL>
-                    <a:lnR w="0" cap="flat" cmpd="sng" algn="ctr">
-                      <a:noFill/>
-                    </a:lnR>
-                    <a:lnT w="0" cap="flat" cmpd="sng" algn="ctr">
-                      <a:noFill/>
-                    </a:lnT>
-                    <a:lnB w="6350" cap="flat" cmpd="sng" algn="ctr">
-                      <a:solidFill>
-                        <a:srgbClr val="E5DDD0"/>
-                      </a:solidFill>
-                      <a:prstDash val="solid"/>
-                      <a:round/>
-                      <a:headEnd type="none" w="med" len="med"/>
-                      <a:tailEnd type="none" w="med" len="med"/>
-                    </a:lnB>
-                    <a:solidFill>
-                      <a:srgbClr val="FFFFFF"/>
-                    </a:solidFill>
-                  </a:tcPr>
-                </a:tc>
-                <a:tc>
-                  <a:txBody>
-                    <a:bodyPr/>
-                    <a:lstStyle/>
-                    <a:p>
-                      <a:pPr algn="ctr" indent="0" marL="0">
-                        <a:buNone/>
-                      </a:pPr>
-                      <a:r>
-                        <a:rPr lang="en-US" sz="800" dirty="0">
-                          <a:solidFill>
-                            <a:srgbClr val="8A7A62"/>
-                          </a:solidFill>
-                          <a:latin typeface="Arial" pitchFamily="34" charset="0"/>
-                          <a:ea typeface="Arial" pitchFamily="34" charset="-122"/>
-                          <a:cs typeface="Arial" pitchFamily="34" charset="-120"/>
-                        </a:rPr>
-                        <a:t>–</a:t>
-                      </a:r>
-                      <a:endParaRPr lang="en-US" sz="800" dirty="0">
+                      <a:endParaRPr lang="en-US" sz="680" dirty="0">
                         <a:latin typeface="Arial" charset="0"/>
                         <a:ea typeface="Arial" charset="0"/>
                         <a:cs typeface="Arial" charset="0"/>
@@ -41675,7 +41675,7 @@
                         <a:buNone/>
                       </a:pPr>
                       <a:r>
-                        <a:rPr lang="en-US" sz="800" dirty="0">
+                        <a:rPr lang="en-US" sz="680" dirty="0">
                           <a:solidFill>
                             <a:srgbClr val="8A7A62"/>
                           </a:solidFill>
@@ -41683,9 +41683,9 @@
                           <a:ea typeface="Arial" pitchFamily="34" charset="-122"/>
                           <a:cs typeface="Arial" pitchFamily="34" charset="-120"/>
                         </a:rPr>
-                        <a:t>–</a:t>
+                        <a:t>Limited</a:t>
                       </a:r>
-                      <a:endParaRPr lang="en-US" sz="800" dirty="0">
+                      <a:endParaRPr lang="en-US" sz="680" dirty="0">
                         <a:latin typeface="Arial" charset="0"/>
                         <a:ea typeface="Arial" charset="0"/>
                         <a:cs typeface="Arial" charset="0"/>
@@ -41725,17 +41725,17 @@
                         <a:buNone/>
                       </a:pPr>
                       <a:r>
-                        <a:rPr lang="en-US" sz="800" dirty="0">
+                        <a:rPr lang="en-US" sz="850" b="1" dirty="0">
                           <a:solidFill>
-                            <a:srgbClr val="8A7A62"/>
+                            <a:srgbClr val="1E1208"/>
                           </a:solidFill>
                           <a:latin typeface="Arial" pitchFamily="34" charset="0"/>
                           <a:ea typeface="Arial" pitchFamily="34" charset="-122"/>
                           <a:cs typeface="Arial" pitchFamily="34" charset="-120"/>
                         </a:rPr>
-                        <a:t>–</a:t>
+                        <a:t>✔</a:t>
                       </a:r>
-                      <a:endParaRPr lang="en-US" sz="800" dirty="0">
+                      <a:endParaRPr lang="en-US" sz="850" dirty="0">
                         <a:latin typeface="Arial" charset="0"/>
                         <a:ea typeface="Arial" charset="0"/>
                         <a:cs typeface="Arial" charset="0"/>
@@ -41877,17 +41877,17 @@
                         <a:buNone/>
                       </a:pPr>
                       <a:r>
-                        <a:rPr lang="en-US" sz="680" dirty="0">
+                        <a:rPr lang="en-US" sz="850" b="1" dirty="0">
                           <a:solidFill>
-                            <a:srgbClr val="8A7A62"/>
+                            <a:srgbClr val="1E1208"/>
                           </a:solidFill>
                           <a:latin typeface="Arial" pitchFamily="34" charset="0"/>
                           <a:ea typeface="Arial" pitchFamily="34" charset="-122"/>
                           <a:cs typeface="Arial" pitchFamily="34" charset="-120"/>
                         </a:rPr>
-                        <a:t>Limited</a:t>
+                        <a:t>✔</a:t>
                       </a:r>
-                      <a:endParaRPr lang="en-US" sz="680" dirty="0">
+                      <a:endParaRPr lang="en-US" sz="850" dirty="0">
                         <a:latin typeface="Arial" charset="0"/>
                         <a:ea typeface="Arial" charset="0"/>
                         <a:cs typeface="Arial" charset="0"/>
@@ -43250,7 +43250,7 @@
                         <a:buNone/>
                       </a:pPr>
                       <a:r>
-                        <a:rPr lang="en-US" sz="800" dirty="0">
+                        <a:rPr lang="en-US" sz="680" dirty="0">
                           <a:solidFill>
                             <a:srgbClr val="8A7A62"/>
                           </a:solidFill>
@@ -43258,9 +43258,9 @@
                           <a:ea typeface="Arial" pitchFamily="34" charset="-122"/>
                           <a:cs typeface="Arial" pitchFamily="34" charset="-120"/>
                         </a:rPr>
-                        <a:t>–</a:t>
+                        <a:t>Limited</a:t>
                       </a:r>
-                      <a:endParaRPr lang="en-US" sz="800" dirty="0">
+                      <a:endParaRPr lang="en-US" sz="680" dirty="0">
                         <a:latin typeface="Arial" charset="0"/>
                         <a:ea typeface="Arial" charset="0"/>
                         <a:cs typeface="Arial" charset="0"/>
@@ -44473,7 +44473,7 @@
                         <a:buNone/>
                       </a:pPr>
                       <a:r>
-                        <a:rPr lang="en-US" sz="800" dirty="0">
+                        <a:rPr lang="en-US" sz="680" dirty="0">
                           <a:solidFill>
                             <a:srgbClr val="8A7A62"/>
                           </a:solidFill>
@@ -44481,9 +44481,9 @@
                           <a:ea typeface="Arial" pitchFamily="34" charset="-122"/>
                           <a:cs typeface="Arial" pitchFamily="34" charset="-120"/>
                         </a:rPr>
-                        <a:t>–</a:t>
+                        <a:t>Limited</a:t>
                       </a:r>
-                      <a:endParaRPr lang="en-US" sz="800" dirty="0">
+                      <a:endParaRPr lang="en-US" sz="680" dirty="0">
                         <a:latin typeface="Arial" charset="0"/>
                         <a:ea typeface="Arial" charset="0"/>
                         <a:cs typeface="Arial" charset="0"/>

</xml_diff>